<commit_message>
feat: finalize LexHub MVP
</commit_message>
<xml_diff>
--- a/LexHub_Pitch_Deck ENG.pptx
+++ b/LexHub_Pitch_Deck ENG.pptx
@@ -15407,7 +15407,7 @@
         <p:spPr>
           <a:xfrm>
             <a:off x="786384" y="3877056"/>
-            <a:ext cx="1691640" cy="365760"/>
+            <a:ext cx="1691640" cy="343556"/>
           </a:xfrm>
           <a:prstGeom prst="rect">
             <a:avLst/>
@@ -15420,20 +15420,35 @@
           </a:bodyPr>
           <a:lstStyle/>
           <a:p>
-            <a:pPr algn="l">
+            <a:pPr algn="ctr">
               <a:lnSpc>
                 <a:spcPct val="115000"/>
               </a:lnSpc>
             </a:pPr>
             <a:r>
-              <a:rPr sz="1000" b="1" i="0">
+              <a:rPr sz="1000" b="1" i="0" dirty="0">
                 <a:solidFill>
                   <a:srgbClr val="1F6FEB"/>
                 </a:solidFill>
                 <a:latin typeface="Calibri"/>
               </a:rPr>
-              <a:t>Product Manager / Full-Stack</a:t>
-            </a:r>
+              <a:t>Product Manager / </a:t>
+            </a:r>
+            <a:r>
+              <a:rPr lang="uz-Latn-UZ" sz="1000" b="1" i="0" dirty="0">
+                <a:solidFill>
+                  <a:srgbClr val="1F6FEB"/>
+                </a:solidFill>
+                <a:latin typeface="Calibri"/>
+              </a:rPr>
+              <a:t>Mobile Developer</a:t>
+            </a:r>
+            <a:endParaRPr sz="1000" b="1" i="0" dirty="0">
+              <a:solidFill>
+                <a:srgbClr val="1F6FEB"/>
+              </a:solidFill>
+              <a:latin typeface="Calibri"/>
+            </a:endParaRPr>
           </a:p>
         </p:txBody>
       </p:sp>
@@ -15537,86 +15552,6 @@
       </p:sp>
       <p:sp>
         <p:nvSpPr>
-          <p:cNvPr id="12" name="Oval 11"/>
-          <p:cNvSpPr/>
-          <p:nvPr/>
-        </p:nvSpPr>
-        <p:spPr>
-          <a:xfrm>
-            <a:off x="3026664" y="2505456"/>
-            <a:ext cx="658368" cy="658368"/>
-          </a:xfrm>
-          <a:prstGeom prst="ellipse">
-            <a:avLst/>
-          </a:prstGeom>
-          <a:solidFill>
-            <a:srgbClr val="0A1733"/>
-          </a:solidFill>
-          <a:ln>
-            <a:noFill/>
-          </a:ln>
-          <a:effectLst/>
-        </p:spPr>
-        <p:style>
-          <a:lnRef idx="1">
-            <a:schemeClr val="accent1"/>
-          </a:lnRef>
-          <a:fillRef idx="3">
-            <a:schemeClr val="accent1"/>
-          </a:fillRef>
-          <a:effectRef idx="2">
-            <a:schemeClr val="accent1"/>
-          </a:effectRef>
-          <a:fontRef idx="minor">
-            <a:schemeClr val="lt1"/>
-          </a:fontRef>
-        </p:style>
-        <p:txBody>
-          <a:bodyPr wrap="square" rtlCol="0" anchor="ctr"/>
-          <a:lstStyle/>
-          <a:p>
-            <a:pPr algn="ctr"/>
-            <a:endParaRPr/>
-          </a:p>
-        </p:txBody>
-      </p:sp>
-      <p:sp>
-        <p:nvSpPr>
-          <p:cNvPr id="13" name="TextBox 12"/>
-          <p:cNvSpPr txBox="1"/>
-          <p:nvPr/>
-        </p:nvSpPr>
-        <p:spPr>
-          <a:xfrm>
-            <a:off x="3026664" y="2514600"/>
-            <a:ext cx="658368" cy="640080"/>
-          </a:xfrm>
-          <a:prstGeom prst="rect">
-            <a:avLst/>
-          </a:prstGeom>
-          <a:noFill/>
-        </p:spPr>
-        <p:txBody>
-          <a:bodyPr wrap="square" lIns="0" tIns="0" rIns="0" bIns="0" anchor="ctr">
-            <a:spAutoFit/>
-          </a:bodyPr>
-          <a:lstStyle/>
-          <a:p>
-            <a:pPr algn="ctr"/>
-            <a:r>
-              <a:rPr sz="1500" b="1" i="0">
-                <a:solidFill>
-                  <a:srgbClr val="C8A265"/>
-                </a:solidFill>
-                <a:latin typeface="Cambria"/>
-              </a:rPr>
-              <a:t>AA</a:t>
-            </a:r>
-          </a:p>
-        </p:txBody>
-      </p:sp>
-      <p:sp>
-        <p:nvSpPr>
           <p:cNvPr id="14" name="TextBox 13"/>
           <p:cNvSpPr txBox="1"/>
           <p:nvPr/>
@@ -15682,7 +15617,7 @@
           </a:bodyPr>
           <a:lstStyle/>
           <a:p>
-            <a:pPr algn="l">
+            <a:pPr algn="ctr">
               <a:lnSpc>
                 <a:spcPct val="115000"/>
               </a:lnSpc>
@@ -15694,7 +15629,16 @@
                 </a:solidFill>
                 <a:latin typeface="Calibri"/>
               </a:rPr>
-              <a:t>Backend Engineer</a:t>
+              <a:t>Backend </a:t>
+            </a:r>
+            <a:r>
+              <a:rPr lang="uz-Latn-UZ" sz="1000" b="1" i="0" dirty="0">
+                <a:solidFill>
+                  <a:srgbClr val="1F6FEB"/>
+                </a:solidFill>
+                <a:latin typeface="Calibri"/>
+              </a:rPr>
+              <a:t>Developer</a:t>
             </a:r>
             <a:endParaRPr sz="1000" b="1" i="0" dirty="0">
               <a:solidFill>
@@ -15811,7 +15755,7 @@
         </p:nvSpPr>
         <p:spPr>
           <a:xfrm>
-            <a:off x="5673852" y="2505456"/>
+            <a:off x="5749017" y="2505456"/>
             <a:ext cx="658368" cy="658368"/>
           </a:xfrm>
           <a:prstGeom prst="ellipse">
@@ -15856,7 +15800,7 @@
         </p:nvSpPr>
         <p:spPr>
           <a:xfrm>
-            <a:off x="5673852" y="2706338"/>
+            <a:off x="5724144" y="2706338"/>
             <a:ext cx="658368" cy="230832"/>
           </a:xfrm>
           <a:prstGeom prst="rect">
@@ -15943,7 +15887,7 @@
         <p:spPr>
           <a:xfrm>
             <a:off x="5266944" y="3877056"/>
-            <a:ext cx="1691640" cy="365760"/>
+            <a:ext cx="1691640" cy="166584"/>
           </a:xfrm>
           <a:prstGeom prst="rect">
             <a:avLst/>
@@ -15956,7 +15900,7 @@
           </a:bodyPr>
           <a:lstStyle/>
           <a:p>
-            <a:pPr algn="l">
+            <a:pPr algn="ctr">
               <a:lnSpc>
                 <a:spcPct val="115000"/>
               </a:lnSpc>
@@ -16146,7 +16090,7 @@
         </p:nvSpPr>
         <p:spPr>
           <a:xfrm>
-            <a:off x="7287768" y="2286000"/>
+            <a:off x="7355803" y="2286000"/>
             <a:ext cx="2112264" cy="2962656"/>
           </a:xfrm>
           <a:prstGeom prst="roundRect">
@@ -16199,7 +16143,7 @@
         </p:nvSpPr>
         <p:spPr>
           <a:xfrm>
-            <a:off x="7854696" y="2505456"/>
+            <a:off x="8001000" y="2505456"/>
             <a:ext cx="658368" cy="658368"/>
           </a:xfrm>
           <a:prstGeom prst="ellipse">
@@ -16244,7 +16188,7 @@
         </p:nvSpPr>
         <p:spPr>
           <a:xfrm>
-            <a:off x="7836408" y="2713536"/>
+            <a:off x="8001000" y="2706338"/>
             <a:ext cx="658368" cy="230832"/>
           </a:xfrm>
           <a:prstGeom prst="rect">
@@ -16353,19 +16297,19 @@
           </a:bodyPr>
           <a:lstStyle/>
           <a:p>
-            <a:pPr algn="l">
+            <a:pPr algn="ctr">
               <a:lnSpc>
                 <a:spcPct val="115000"/>
               </a:lnSpc>
             </a:pPr>
             <a:r>
-              <a:rPr lang="en" sz="1000" b="1" i="0" dirty="0">
+              <a:rPr lang="uz-Latn-UZ" sz="1000" b="1" i="0" dirty="0">
                 <a:solidFill>
                   <a:srgbClr val="1F6FEB"/>
                 </a:solidFill>
                 <a:latin typeface="Calibri"/>
               </a:rPr>
-              <a:t>Business &amp; Growth Analyst</a:t>
+              <a:t>ML Engineer</a:t>
             </a:r>
             <a:endParaRPr sz="1000" b="1" i="0" dirty="0">
               <a:solidFill>
@@ -16491,7 +16435,7 @@
         </p:nvSpPr>
         <p:spPr>
           <a:xfrm>
-            <a:off x="10076688" y="2496312"/>
+            <a:off x="10200132" y="2505456"/>
             <a:ext cx="658368" cy="658368"/>
           </a:xfrm>
           <a:prstGeom prst="ellipse">
@@ -16536,7 +16480,7 @@
         </p:nvSpPr>
         <p:spPr>
           <a:xfrm>
-            <a:off x="10076688" y="2719224"/>
+            <a:off x="10200132" y="2719224"/>
             <a:ext cx="658368" cy="230832"/>
           </a:xfrm>
           <a:prstGeom prst="rect">
@@ -16591,7 +16535,7 @@
           </a:bodyPr>
           <a:lstStyle/>
           <a:p>
-            <a:pPr algn="l">
+            <a:pPr algn="ctr">
               <a:lnSpc>
                 <a:spcPct val="110000"/>
               </a:lnSpc>
@@ -16623,7 +16567,7 @@
         <p:spPr>
           <a:xfrm>
             <a:off x="9747504" y="3877056"/>
-            <a:ext cx="1691640" cy="365760"/>
+            <a:ext cx="1691640" cy="166584"/>
           </a:xfrm>
           <a:prstGeom prst="rect">
             <a:avLst/>
@@ -16636,20 +16580,26 @@
           </a:bodyPr>
           <a:lstStyle/>
           <a:p>
-            <a:pPr algn="l">
+            <a:pPr algn="ctr">
               <a:lnSpc>
                 <a:spcPct val="115000"/>
               </a:lnSpc>
             </a:pPr>
             <a:r>
-              <a:rPr sz="1000" b="1" i="0" dirty="0">
+              <a:rPr lang="uz-Latn-UZ" sz="1000" b="1" i="0" dirty="0">
                 <a:solidFill>
                   <a:srgbClr val="1F6FEB"/>
                 </a:solidFill>
                 <a:latin typeface="Calibri"/>
               </a:rPr>
-              <a:t>Pitcher / Growth</a:t>
-            </a:r>
+              <a:t>Tester</a:t>
+            </a:r>
+            <a:endParaRPr sz="1000" b="1" i="0" dirty="0">
+              <a:solidFill>
+                <a:srgbClr val="1F6FEB"/>
+              </a:solidFill>
+              <a:latin typeface="Calibri"/>
+            </a:endParaRPr>
           </a:p>
         </p:txBody>
       </p:sp>
@@ -17043,8 +16993,8 @@
         </p:blipFill>
         <p:spPr>
           <a:xfrm>
-            <a:off x="2993136" y="2212848"/>
-            <a:ext cx="1114100" cy="1122540"/>
+            <a:off x="3323343" y="2234709"/>
+            <a:ext cx="1074754" cy="1082896"/>
           </a:xfrm>
           <a:prstGeom prst="flowChartConnector">
             <a:avLst/>

</xml_diff>